<commit_message>
Remove book-source wording from lesson decks
</commit_message>
<xml_diff>
--- a/02차시_CommandPattern/강의자료/유니티 프로그래밍 패턴 2차시 - Command Pattern.pptx
+++ b/02차시_CommandPattern/강의자료/유니티 프로그래밍 패턴 2차시 - Command Pattern.pptx
@@ -541,7 +541,7 @@
           <a:p>
             <a:r>
               <a:rPr lang="en-US" dirty="0"/>
-              <a:t>오늘은 Game Programming Patterns의 Command 장을 Unity/C# 수업으로 다룬다. 핵심 목표는 '버튼을 누르면 바로 함수 호출'이라는 구조를 '실행할 일을 객체로 만든다'는 구조로 바꾸는 것이다.</a:t>
+              <a:t>오늘은 Command 패턴을 Unity/C# 수업으로 다룬다. 핵심 목표는 '버튼을 누르면 바로 함수 호출'이라는 구조를 '실행할 일을 객체로 만든다'는 구조로 바꾸는 것이다.</a:t>
             </a:r>
             <a:endParaRPr lang="en-US" dirty="0"/>
           </a:p>
@@ -629,7 +629,7 @@
           <a:p>
             <a:r>
               <a:rPr lang="en-US" dirty="0"/>
-              <a:t>원문은 Null Object를 함께 언급한다.</a:t>
+              <a:t>예제에서는 Null Object를 함께 언급한다.</a:t>
             </a:r>
             <a:endParaRPr lang="en-US" dirty="0"/>
           </a:p>
@@ -717,7 +717,7 @@
           <a:p>
             <a:r>
               <a:rPr lang="en-US" dirty="0"/>
-              <a:t>원문의 컨트롤러 매핑 설명을 Unity 관점으로 시각화했다.</a:t>
+              <a:t>컨트롤러 매핑 구조를 Unity 관점으로 시각화했다.</a:t>
             </a:r>
             <a:endParaRPr lang="en-US" dirty="0"/>
           </a:p>
@@ -805,7 +805,7 @@
           <a:p>
             <a:r>
               <a:rPr lang="en-US" dirty="0"/>
-              <a:t>원문의 Directions for Actors 절이다.</a:t>
+              <a:t>Actor에게 명령을 전달하는 구조를 다룬다.</a:t>
             </a:r>
             <a:endParaRPr lang="en-US" dirty="0"/>
           </a:p>
@@ -893,7 +893,7 @@
           <a:p>
             <a:r>
               <a:rPr lang="en-US" dirty="0"/>
-              <a:t>원문에서는 Command::execute(GameActor&amp; actor)로 표현한다.</a:t>
+              <a:t>예제에서는 Command::execute(GameActor&amp; actor)로 표현한다.</a:t>
             </a:r>
             <a:endParaRPr lang="en-US" dirty="0"/>
           </a:p>
@@ -981,7 +981,7 @@
           <a:p>
             <a:r>
               <a:rPr lang="en-US" dirty="0"/>
-              <a:t>원문은 handleInput()이 Command 포인터를 반환한다.</a:t>
+              <a:t>예제에서는 handleInput()이 Command 포인터를 반환한다.</a:t>
             </a:r>
             <a:endParaRPr lang="en-US" dirty="0"/>
           </a:p>
@@ -1157,7 +1157,7 @@
           <a:p>
             <a:r>
               <a:rPr lang="en-US" dirty="0"/>
-              <a:t>원문은 AI 엔진이 Command를 내보내면 Actor 코드와 AI 선택 로직이 분리된다고 설명한다.</a:t>
+              <a:t>예제에서는 AI 엔진이 Command를 내보내면 Actor 코드와 AI 선택 로직이 분리된다고 설명한다.</a:t>
             </a:r>
             <a:endParaRPr lang="en-US" dirty="0"/>
           </a:p>
@@ -1245,7 +1245,7 @@
           <a:p>
             <a:r>
               <a:rPr lang="en-US" dirty="0"/>
-              <a:t>원문은 명령을 스트림으로 생각하라고 한다.</a:t>
+              <a:t>예제에서는 명령을 스트림으로 생각하라고 한다.</a:t>
             </a:r>
             <a:endParaRPr lang="en-US" dirty="0"/>
           </a:p>
@@ -1333,7 +1333,7 @@
           <a:p>
             <a:r>
               <a:rPr lang="en-US" dirty="0"/>
-              <a:t>원문은 네트워크 멀티플레이와 리플레이에서 Command Stream이 유용하다고 설명한다.</a:t>
+              <a:t>예제에서는 네트워크 멀티플레이와 리플레이에서 Command Stream이 유용하다고 설명한다.</a:t>
             </a:r>
             <a:endParaRPr lang="en-US" dirty="0"/>
           </a:p>
@@ -1421,7 +1421,7 @@
           <a:p>
             <a:r>
               <a:rPr lang="en-US" dirty="0"/>
-              <a:t>원문은 Command 패턴의 대표 사례로 Undo를 다룬다.</a:t>
+              <a:t>예제에서는 Command 패턴의 대표 사례로 Undo를 다룬다.</a:t>
             </a:r>
             <a:endParaRPr lang="en-US" dirty="0"/>
           </a:p>
@@ -1509,7 +1509,7 @@
           <a:p>
             <a:r>
               <a:rPr lang="en-US" dirty="0"/>
-              <a:t>원문 출처는 Robert Nystrom의 Game Programming Patterns, Command 장이다. 슬라이드에는 원문을 그대로 길게 옮기지 않고 수업용 설명으로 재구성했다. 전체 흐름은 입력 설정, Actor 대상 분리, Command Stream, 네트워크와 리플레이, Undo/Redo, 함수형 대안, 관련 패턴 순서다.</a:t>
+              <a:t>수업 흐름은 입력 설정, Actor 대상 분리, Command Stream, 네트워크와 리플레이, Undo/Redo, 함수형 대안, 관련 패턴 순서다.</a:t>
             </a:r>
             <a:endParaRPr lang="en-US" dirty="0"/>
           </a:p>
@@ -1685,7 +1685,7 @@
           <a:p>
             <a:r>
               <a:rPr lang="en-US" dirty="0"/>
-              <a:t>원문의 MoveUnitCommand는 특정 유닛과 목적지 좌표를 가진다.</a:t>
+              <a:t>MoveUnitCommand는 특정 유닛과 목적지 좌표를 가진다.</a:t>
             </a:r>
             <a:endParaRPr lang="en-US" dirty="0"/>
           </a:p>
@@ -1773,7 +1773,7 @@
           <a:p>
             <a:r>
               <a:rPr lang="en-US" dirty="0"/>
-              <a:t>원문은 xBefore_, yBefore_를 저장한다.</a:t>
+              <a:t>예제에서는 xBefore_, yBefore_를 저장한다.</a:t>
             </a:r>
             <a:endParaRPr lang="en-US" dirty="0"/>
           </a:p>
@@ -1861,7 +1861,7 @@
           <a:p>
             <a:r>
               <a:rPr lang="en-US" dirty="0"/>
-              <a:t>원문은 방향 입력마다 새 MoveUnitCommand를 만든다.</a:t>
+              <a:t>예제에서는 방향 입력마다 새 MoveUnitCommand를 만든다.</a:t>
             </a:r>
             <a:endParaRPr lang="en-US" dirty="0"/>
           </a:p>
@@ -2037,7 +2037,7 @@
           <a:p>
             <a:r>
               <a:rPr lang="en-US" dirty="0"/>
-              <a:t>원문의 Undo/Redo 설명을 C# 리스트와 current 인덱스로 구현한 형태다.</a:t>
+              <a:t>Undo/Redo 흐름을 C# 리스트와 current 인덱스로 구현한 형태다.</a:t>
             </a:r>
             <a:endParaRPr lang="en-US" dirty="0"/>
           </a:p>
@@ -2213,7 +2213,7 @@
           <a:p>
             <a:r>
               <a:rPr lang="en-US" dirty="0"/>
-              <a:t>원문은 Redo보다 Replay가 게임에서 더 흔할 수 있다고 한다.</a:t>
+              <a:t>예제에서는 Redo보다 Replay가 게임에서 더 흔할 수 있다고 한다.</a:t>
             </a:r>
             <a:endParaRPr lang="en-US" dirty="0"/>
           </a:p>
@@ -2301,7 +2301,7 @@
           <a:p>
             <a:r>
               <a:rPr lang="en-US" dirty="0"/>
-              <a:t>원문은 JavaScript 클로저 예시로 함수형 Command를 설명한다.</a:t>
+              <a:t>예제에서는 JavaScript 클로저 예시로 함수형 Command를 설명한다.</a:t>
             </a:r>
             <a:endParaRPr lang="en-US" dirty="0"/>
           </a:p>
@@ -2477,7 +2477,7 @@
           <a:p>
             <a:r>
               <a:rPr lang="en-US" dirty="0"/>
-              <a:t>원문 출처는 Robert Nystrom의 Game Programming Patterns, Command 장이다. 슬라이드에는 원문을 그대로 길게 옮기지 않고 수업용 설명으로 재구성했다. 전체 흐름은 입력 설정, Actor 대상 분리, Command Stream, 네트워크와 리플레이, Undo/Redo, 함수형 대안, 관련 패턴 순서다.</a:t>
+              <a:t>수업 흐름은 입력 설정, Actor 대상 분리, Command Stream, 네트워크와 리플레이, Undo/Redo, 함수형 대안, 관련 패턴 순서다.</a:t>
             </a:r>
             <a:endParaRPr lang="en-US" dirty="0"/>
           </a:p>
@@ -2565,7 +2565,7 @@
           <a:p>
             <a:r>
               <a:rPr lang="en-US" dirty="0"/>
-              <a:t>원문 마지막 See Also 절의 내용이다.</a:t>
+              <a:t>관련 패턴을 함께 정리한다.</a:t>
             </a:r>
             <a:endParaRPr lang="en-US" dirty="0"/>
           </a:p>
@@ -3357,7 +3357,7 @@
           <a:p>
             <a:r>
               <a:rPr lang="en-US" dirty="0"/>
-              <a:t>확장 과제는 원문의 입력 설정, Actor 분리, 리플레이, AI 응용으로 이어진다.</a:t>
+              <a:t>확장 과제는 예제의 입력 설정, Actor 분리, 리플레이, AI 응용으로 이어진다.</a:t>
             </a:r>
             <a:endParaRPr lang="en-US" dirty="0"/>
           </a:p>
@@ -3445,7 +3445,7 @@
           <a:p>
             <a:r>
               <a:rPr lang="en-US" dirty="0"/>
-              <a:t>원문 출처는 Robert Nystrom의 Game Programming Patterns, Command 장이다. 슬라이드에는 원문을 그대로 길게 옮기지 않고 수업용 설명으로 재구성했다. 전체 흐름은 입력 설정, Actor 대상 분리, Command Stream, 네트워크와 리플레이, Undo/Redo, 함수형 대안, 관련 패턴 순서다.</a:t>
+              <a:t>수업 흐름은 입력 설정, Actor 대상 분리, Command Stream, 네트워크와 리플레이, Undo/Redo, 함수형 대안, 관련 패턴 순서다.</a:t>
             </a:r>
             <a:endParaRPr lang="en-US" dirty="0"/>
           </a:p>
@@ -3621,7 +3621,7 @@
           <a:p>
             <a:r>
               <a:rPr lang="en-US" dirty="0"/>
-              <a:t>원문은 X/Y/A/B 버튼이 jump, fireGun, swapWeapon, lurchIneffectively를 직접 호출하는 코드에서 시작한다.</a:t>
+              <a:t>예제에서는 X/Y/A/B 버튼이 jump, fireGun, swapWeapon, lurchIneffectively를 직접 호출하는 코드에서 시작한다.</a:t>
             </a:r>
             <a:endParaRPr lang="en-US" dirty="0"/>
           </a:p>
@@ -3797,7 +3797,7 @@
           <a:p>
             <a:r>
               <a:rPr lang="en-US" dirty="0"/>
-              <a:t>원문의 핵심 표현은 reified method call이다.</a:t>
+              <a:t>핵심 표현은 reified method call이다.</a:t>
             </a:r>
             <a:endParaRPr lang="en-US" dirty="0"/>
           </a:p>
@@ -3885,7 +3885,7 @@
           <a:p>
             <a:r>
               <a:rPr lang="en-US" dirty="0"/>
-              <a:t>원문의 C++ 추상 클래스 Command를 C# 인터페이스로 바꾼 예시다.</a:t>
+              <a:t>Command 추상 구조를 C# 인터페이스로 바꾼 예시다.</a:t>
             </a:r>
             <a:endParaRPr lang="en-US" dirty="0"/>
           </a:p>
@@ -3973,7 +3973,7 @@
           <a:p>
             <a:r>
               <a:rPr lang="en-US" dirty="0"/>
-              <a:t>원문에서 InputHandler가 buttonX_, buttonY_ 포인터를 들고 있던 구조를 C# 프로퍼티로 표현했다.</a:t>
+              <a:t>예제에서 InputHandler가 buttonX_, buttonY_ 포인터를 들고 있던 구조를 C# 프로퍼티로 표현했다.</a:t>
             </a:r>
             <a:endParaRPr lang="en-US" dirty="0"/>
           </a:p>
@@ -4893,7 +4893,7 @@
                 <a:ea typeface="Malgun Gothic" pitchFamily="34" charset="-122"/>
                 <a:cs typeface="Malgun Gothic" pitchFamily="34" charset="-120"/>
               </a:rPr>
-              <a:t>Game Programming Patterns · Unity/C#</a:t>
+              <a:t>Unity/C# 설계 패턴</a:t>
             </a:r>
             <a:endParaRPr lang="en-US" sz="1050" dirty="0"/>
           </a:p>
@@ -5053,7 +5053,7 @@
                 <a:ea typeface="Malgun Gothic" pitchFamily="34" charset="-122"/>
                 <a:cs typeface="Malgun Gothic" pitchFamily="34" charset="-120"/>
               </a:rPr>
-              <a:t>Game Programming Patterns - Command | Unity/C#</a:t>
+              <a:t>Command | Unity/C#</a:t>
             </a:r>
             <a:endParaRPr lang="en-US" sz="700" dirty="0"/>
           </a:p>
@@ -5239,7 +5239,7 @@
                 <a:ea typeface="Consolas" pitchFamily="34" charset="-122"/>
                 <a:cs typeface="Consolas" pitchFamily="34" charset="-120"/>
               </a:rPr>
-              <a:t>    public void Execute()</a:t>
+              <a:t>public void Execute()</a:t>
             </a:r>
             <a:endParaRPr lang="en-US" sz="1320" dirty="0"/>
           </a:p>
@@ -5256,7 +5256,7 @@
                 <a:ea typeface="Consolas" pitchFamily="34" charset="-122"/>
                 <a:cs typeface="Consolas" pitchFamily="34" charset="-120"/>
               </a:rPr>
-              <a:t>    {</a:t>
+              <a:t>{</a:t>
             </a:r>
             <a:endParaRPr lang="en-US" sz="1320" dirty="0"/>
           </a:p>
@@ -5273,7 +5273,7 @@
                 <a:ea typeface="Consolas" pitchFamily="34" charset="-122"/>
                 <a:cs typeface="Consolas" pitchFamily="34" charset="-120"/>
               </a:rPr>
-              <a:t>        // Intentionally empty.</a:t>
+              <a:t>// Intentionally empty.</a:t>
             </a:r>
             <a:endParaRPr lang="en-US" sz="1320" dirty="0"/>
           </a:p>
@@ -5290,7 +5290,7 @@
                 <a:ea typeface="Consolas" pitchFamily="34" charset="-122"/>
                 <a:cs typeface="Consolas" pitchFamily="34" charset="-120"/>
               </a:rPr>
-              <a:t>    }</a:t>
+              <a:t>}</a:t>
             </a:r>
             <a:endParaRPr lang="en-US" sz="1320" dirty="0"/>
           </a:p>
@@ -5490,7 +5490,7 @@
                 <a:ea typeface="Malgun Gothic" pitchFamily="34" charset="-122"/>
                 <a:cs typeface="Malgun Gothic" pitchFamily="34" charset="-120"/>
               </a:rPr>
-              <a:t>Game Programming Patterns - Command | Unity/C#</a:t>
+              <a:t>Command | Unity/C#</a:t>
             </a:r>
             <a:endParaRPr lang="en-US" sz="700" dirty="0"/>
           </a:p>
@@ -6244,7 +6244,7 @@
                 <a:ea typeface="Malgun Gothic" pitchFamily="34" charset="-122"/>
                 <a:cs typeface="Malgun Gothic" pitchFamily="34" charset="-120"/>
               </a:rPr>
-              <a:t>Game Programming Patterns - Command | Unity/C#</a:t>
+              <a:t>Command | Unity/C#</a:t>
             </a:r>
             <a:endParaRPr lang="en-US" sz="700" dirty="0"/>
           </a:p>
@@ -6923,7 +6923,7 @@
                 <a:ea typeface="Malgun Gothic" pitchFamily="34" charset="-122"/>
                 <a:cs typeface="Malgun Gothic" pitchFamily="34" charset="-120"/>
               </a:rPr>
-              <a:t>Game Programming Patterns - Command | Unity/C#</a:t>
+              <a:t>Command | Unity/C#</a:t>
             </a:r>
             <a:endParaRPr lang="en-US" sz="700" dirty="0"/>
           </a:p>
@@ -7109,7 +7109,7 @@
                 <a:ea typeface="Consolas" pitchFamily="34" charset="-122"/>
                 <a:cs typeface="Consolas" pitchFamily="34" charset="-120"/>
               </a:rPr>
-              <a:t>    void Execute(GameActor actor);</a:t>
+              <a:t>void Execute(GameActor actor);</a:t>
             </a:r>
             <a:endParaRPr lang="en-US" sz="1300" dirty="0"/>
           </a:p>
@@ -7183,7 +7183,7 @@
                 <a:ea typeface="Consolas" pitchFamily="34" charset="-122"/>
                 <a:cs typeface="Consolas" pitchFamily="34" charset="-120"/>
               </a:rPr>
-              <a:t>    public void Execute(GameActor actor)</a:t>
+              <a:t>public void Execute(GameActor actor)</a:t>
             </a:r>
             <a:endParaRPr lang="en-US" sz="1300" dirty="0"/>
           </a:p>
@@ -7200,7 +7200,7 @@
                 <a:ea typeface="Consolas" pitchFamily="34" charset="-122"/>
                 <a:cs typeface="Consolas" pitchFamily="34" charset="-120"/>
               </a:rPr>
-              <a:t>    {</a:t>
+              <a:t>{</a:t>
             </a:r>
             <a:endParaRPr lang="en-US" sz="1300" dirty="0"/>
           </a:p>
@@ -7217,7 +7217,7 @@
                 <a:ea typeface="Consolas" pitchFamily="34" charset="-122"/>
                 <a:cs typeface="Consolas" pitchFamily="34" charset="-120"/>
               </a:rPr>
-              <a:t>        actor.Jump();</a:t>
+              <a:t>actor.Jump();</a:t>
             </a:r>
             <a:endParaRPr lang="en-US" sz="1300" dirty="0"/>
           </a:p>
@@ -7234,7 +7234,7 @@
                 <a:ea typeface="Consolas" pitchFamily="34" charset="-122"/>
                 <a:cs typeface="Consolas" pitchFamily="34" charset="-120"/>
               </a:rPr>
-              <a:t>    }</a:t>
+              <a:t>}</a:t>
             </a:r>
             <a:endParaRPr lang="en-US" sz="1300" dirty="0"/>
           </a:p>
@@ -7411,7 +7411,7 @@
                 <a:ea typeface="Malgun Gothic" pitchFamily="34" charset="-122"/>
                 <a:cs typeface="Malgun Gothic" pitchFamily="34" charset="-120"/>
               </a:rPr>
-              <a:t>Game Programming Patterns - Command | Unity/C#</a:t>
+              <a:t>Command | Unity/C#</a:t>
             </a:r>
             <a:endParaRPr lang="en-US" sz="700" dirty="0"/>
           </a:p>
@@ -7597,7 +7597,7 @@
                 <a:ea typeface="Consolas" pitchFamily="34" charset="-122"/>
                 <a:cs typeface="Consolas" pitchFamily="34" charset="-120"/>
               </a:rPr>
-              <a:t>    if (Input.GetKeyDown(KeyCode.X)) return buttonX;</a:t>
+              <a:t>if (Input.GetKeyDown(KeyCode.X)) return buttonX;</a:t>
             </a:r>
             <a:endParaRPr lang="en-US" sz="1350" dirty="0"/>
           </a:p>
@@ -7614,7 +7614,7 @@
                 <a:ea typeface="Consolas" pitchFamily="34" charset="-122"/>
                 <a:cs typeface="Consolas" pitchFamily="34" charset="-120"/>
               </a:rPr>
-              <a:t>    if (Input.GetKeyDown(KeyCode.Y)) return buttonY;</a:t>
+              <a:t>if (Input.GetKeyDown(KeyCode.Y)) return buttonY;</a:t>
             </a:r>
             <a:endParaRPr lang="en-US" sz="1350" dirty="0"/>
           </a:p>
@@ -7631,7 +7631,7 @@
                 <a:ea typeface="Consolas" pitchFamily="34" charset="-122"/>
                 <a:cs typeface="Consolas" pitchFamily="34" charset="-120"/>
               </a:rPr>
-              <a:t>    return null;</a:t>
+              <a:t>return null;</a:t>
             </a:r>
             <a:endParaRPr lang="en-US" sz="1350" dirty="0"/>
           </a:p>
@@ -7808,7 +7808,7 @@
                 <a:ea typeface="Malgun Gothic" pitchFamily="34" charset="-122"/>
                 <a:cs typeface="Malgun Gothic" pitchFamily="34" charset="-120"/>
               </a:rPr>
-              <a:t>Game Programming Patterns - Command | Unity/C#</a:t>
+              <a:t>Command | Unity/C#</a:t>
             </a:r>
             <a:endParaRPr lang="en-US" sz="700" dirty="0"/>
           </a:p>
@@ -7994,7 +7994,7 @@
                 <a:ea typeface="Consolas" pitchFamily="34" charset="-122"/>
                 <a:cs typeface="Consolas" pitchFamily="34" charset="-120"/>
               </a:rPr>
-              <a:t>    IActorCommand command = HandleInput();</a:t>
+              <a:t>IActorCommand command = HandleInput();</a:t>
             </a:r>
             <a:endParaRPr lang="en-US" sz="1400" dirty="0"/>
           </a:p>
@@ -8017,7 +8017,7 @@
                 <a:ea typeface="Consolas" pitchFamily="34" charset="-122"/>
                 <a:cs typeface="Consolas" pitchFamily="34" charset="-120"/>
               </a:rPr>
-              <a:t>    if (command != null)</a:t>
+              <a:t>if (command != null)</a:t>
             </a:r>
             <a:endParaRPr lang="en-US" sz="1400" dirty="0"/>
           </a:p>
@@ -8034,7 +8034,7 @@
                 <a:ea typeface="Consolas" pitchFamily="34" charset="-122"/>
                 <a:cs typeface="Consolas" pitchFamily="34" charset="-120"/>
               </a:rPr>
-              <a:t>        command.Execute(currentActor);</a:t>
+              <a:t>command.Execute(currentActor);</a:t>
             </a:r>
             <a:endParaRPr lang="en-US" sz="1400" dirty="0"/>
           </a:p>
@@ -8211,7 +8211,7 @@
                 <a:ea typeface="Malgun Gothic" pitchFamily="34" charset="-122"/>
                 <a:cs typeface="Malgun Gothic" pitchFamily="34" charset="-120"/>
               </a:rPr>
-              <a:t>Game Programming Patterns - Command | Unity/C#</a:t>
+              <a:t>Command | Unity/C#</a:t>
             </a:r>
             <a:endParaRPr lang="en-US" sz="700" dirty="0"/>
           </a:p>
@@ -8965,7 +8965,7 @@
                 <a:ea typeface="Malgun Gothic" pitchFamily="34" charset="-122"/>
                 <a:cs typeface="Malgun Gothic" pitchFamily="34" charset="-120"/>
               </a:rPr>
-              <a:t>Game Programming Patterns - Command | Unity/C#</a:t>
+              <a:t>Command | Unity/C#</a:t>
             </a:r>
             <a:endParaRPr lang="en-US" sz="700" dirty="0"/>
           </a:p>
@@ -9719,7 +9719,7 @@
                 <a:ea typeface="Malgun Gothic" pitchFamily="34" charset="-122"/>
                 <a:cs typeface="Malgun Gothic" pitchFamily="34" charset="-120"/>
               </a:rPr>
-              <a:t>Game Programming Patterns - Command | Unity/C#</a:t>
+              <a:t>Command | Unity/C#</a:t>
             </a:r>
             <a:endParaRPr lang="en-US" sz="700" dirty="0"/>
           </a:p>
@@ -10159,7 +10159,7 @@
                 <a:ea typeface="Malgun Gothic" pitchFamily="34" charset="-122"/>
                 <a:cs typeface="Malgun Gothic" pitchFamily="34" charset="-120"/>
               </a:rPr>
-              <a:t>Game Programming Patterns - Command | Unity/C#</a:t>
+              <a:t>Command | Unity/C#</a:t>
             </a:r>
             <a:endParaRPr lang="en-US" sz="700" dirty="0"/>
           </a:p>
@@ -10599,7 +10599,7 @@
                 <a:ea typeface="Malgun Gothic" pitchFamily="34" charset="-122"/>
                 <a:cs typeface="Malgun Gothic" pitchFamily="34" charset="-120"/>
               </a:rPr>
-              <a:t>Game Programming Patterns - Command | Unity/C#</a:t>
+              <a:t>Command | Unity/C#</a:t>
             </a:r>
             <a:endParaRPr lang="en-US" sz="700" dirty="0"/>
           </a:p>
@@ -11064,7 +11064,7 @@
                 <a:ea typeface="Malgun Gothic" pitchFamily="34" charset="-122"/>
                 <a:cs typeface="Malgun Gothic" pitchFamily="34" charset="-120"/>
               </a:rPr>
-              <a:t>Game Programming Patterns - Command | Unity/C#</a:t>
+              <a:t>Command | Unity/C#</a:t>
             </a:r>
             <a:endParaRPr lang="en-US" sz="700" dirty="0"/>
           </a:p>
@@ -11250,7 +11250,7 @@
                 <a:ea typeface="Consolas" pitchFamily="34" charset="-122"/>
                 <a:cs typeface="Consolas" pitchFamily="34" charset="-120"/>
               </a:rPr>
-              <a:t>    void Execute();</a:t>
+              <a:t>void Execute();</a:t>
             </a:r>
             <a:endParaRPr lang="en-US" sz="1500" dirty="0"/>
           </a:p>
@@ -11267,7 +11267,7 @@
                 <a:ea typeface="Consolas" pitchFamily="34" charset="-122"/>
                 <a:cs typeface="Consolas" pitchFamily="34" charset="-120"/>
               </a:rPr>
-              <a:t>    void Undo();</a:t>
+              <a:t>void Undo();</a:t>
             </a:r>
             <a:endParaRPr lang="en-US" sz="1500" dirty="0"/>
           </a:p>
@@ -11444,7 +11444,7 @@
                 <a:ea typeface="Malgun Gothic" pitchFamily="34" charset="-122"/>
                 <a:cs typeface="Malgun Gothic" pitchFamily="34" charset="-120"/>
               </a:rPr>
-              <a:t>Game Programming Patterns - Command | Unity/C#</a:t>
+              <a:t>Command | Unity/C#</a:t>
             </a:r>
             <a:endParaRPr lang="en-US" sz="700" dirty="0"/>
           </a:p>
@@ -11630,7 +11630,7 @@
                 <a:ea typeface="Consolas" pitchFamily="34" charset="-122"/>
                 <a:cs typeface="Consolas" pitchFamily="34" charset="-120"/>
               </a:rPr>
-              <a:t>    private readonly Unit unit;</a:t>
+              <a:t>private readonly Unit unit;</a:t>
             </a:r>
             <a:endParaRPr lang="en-US" sz="1400" dirty="0"/>
           </a:p>
@@ -11647,7 +11647,7 @@
                 <a:ea typeface="Consolas" pitchFamily="34" charset="-122"/>
                 <a:cs typeface="Consolas" pitchFamily="34" charset="-120"/>
               </a:rPr>
-              <a:t>    private readonly Vector2Int destination;</a:t>
+              <a:t>private readonly Vector2Int destination;</a:t>
             </a:r>
             <a:endParaRPr lang="en-US" sz="1400" dirty="0"/>
           </a:p>
@@ -11664,7 +11664,7 @@
                 <a:ea typeface="Consolas" pitchFamily="34" charset="-122"/>
                 <a:cs typeface="Consolas" pitchFamily="34" charset="-120"/>
               </a:rPr>
-              <a:t>    private Vector2Int before;</a:t>
+              <a:t>private Vector2Int before;</a:t>
             </a:r>
             <a:endParaRPr lang="en-US" sz="1400" dirty="0"/>
           </a:p>
@@ -11841,7 +11841,7 @@
                 <a:ea typeface="Malgun Gothic" pitchFamily="34" charset="-122"/>
                 <a:cs typeface="Malgun Gothic" pitchFamily="34" charset="-120"/>
               </a:rPr>
-              <a:t>Game Programming Patterns - Command | Unity/C#</a:t>
+              <a:t>Command | Unity/C#</a:t>
             </a:r>
             <a:endParaRPr lang="en-US" sz="700" dirty="0"/>
           </a:p>
@@ -12027,7 +12027,7 @@
                 <a:ea typeface="Consolas" pitchFamily="34" charset="-122"/>
                 <a:cs typeface="Consolas" pitchFamily="34" charset="-120"/>
               </a:rPr>
-              <a:t>    before = unit.GridPosition;</a:t>
+              <a:t>before = unit.GridPosition;</a:t>
             </a:r>
             <a:endParaRPr lang="en-US" sz="1370" dirty="0"/>
           </a:p>
@@ -12044,7 +12044,7 @@
                 <a:ea typeface="Consolas" pitchFamily="34" charset="-122"/>
                 <a:cs typeface="Consolas" pitchFamily="34" charset="-120"/>
               </a:rPr>
-              <a:t>    unit.MoveTo(destination);</a:t>
+              <a:t>unit.MoveTo(destination);</a:t>
             </a:r>
             <a:endParaRPr lang="en-US" sz="1370" dirty="0"/>
           </a:p>
@@ -12118,7 +12118,7 @@
                 <a:ea typeface="Consolas" pitchFamily="34" charset="-122"/>
                 <a:cs typeface="Consolas" pitchFamily="34" charset="-120"/>
               </a:rPr>
-              <a:t>    unit.MoveTo(before);</a:t>
+              <a:t>unit.MoveTo(before);</a:t>
             </a:r>
             <a:endParaRPr lang="en-US" sz="1370" dirty="0"/>
           </a:p>
@@ -12295,7 +12295,7 @@
                 <a:ea typeface="Malgun Gothic" pitchFamily="34" charset="-122"/>
                 <a:cs typeface="Malgun Gothic" pitchFamily="34" charset="-120"/>
               </a:rPr>
-              <a:t>Game Programming Patterns - Command | Unity/C#</a:t>
+              <a:t>Command | Unity/C#</a:t>
             </a:r>
             <a:endParaRPr lang="en-US" sz="700" dirty="0"/>
           </a:p>
@@ -12487,7 +12487,7 @@
                 <a:ea typeface="Consolas" pitchFamily="34" charset="-122"/>
                 <a:cs typeface="Consolas" pitchFamily="34" charset="-120"/>
               </a:rPr>
-              <a:t>    return new MoveUnitCommand(unit, pos + Vector2Int.up);</a:t>
+              <a:t>return new MoveUnitCommand(unit, pos + Vector2Int.up);</a:t>
             </a:r>
             <a:endParaRPr lang="en-US" sz="1280" dirty="0"/>
           </a:p>
@@ -12527,7 +12527,7 @@
                 <a:ea typeface="Consolas" pitchFamily="34" charset="-122"/>
                 <a:cs typeface="Consolas" pitchFamily="34" charset="-120"/>
               </a:rPr>
-              <a:t>    return new MoveUnitCommand(unit, pos + Vector2Int.down);</a:t>
+              <a:t>return new MoveUnitCommand(unit, pos + Vector2Int.down);</a:t>
             </a:r>
             <a:endParaRPr lang="en-US" sz="1280" dirty="0"/>
           </a:p>
@@ -12710,7 +12710,7 @@
                 <a:ea typeface="Malgun Gothic" pitchFamily="34" charset="-122"/>
                 <a:cs typeface="Malgun Gothic" pitchFamily="34" charset="-120"/>
               </a:rPr>
-              <a:t>Game Programming Patterns - Command | Unity/C#</a:t>
+              <a:t>Command | Unity/C#</a:t>
             </a:r>
             <a:endParaRPr lang="en-US" sz="700" dirty="0"/>
           </a:p>
@@ -12896,7 +12896,7 @@
                 <a:ea typeface="Consolas" pitchFamily="34" charset="-122"/>
                 <a:cs typeface="Consolas" pitchFamily="34" charset="-120"/>
               </a:rPr>
-              <a:t>    commands.RemoveRange(</a:t>
+              <a:t>commands.RemoveRange(</a:t>
             </a:r>
             <a:endParaRPr lang="en-US" sz="1280" dirty="0"/>
           </a:p>
@@ -12913,7 +12913,7 @@
                 <a:ea typeface="Consolas" pitchFamily="34" charset="-122"/>
                 <a:cs typeface="Consolas" pitchFamily="34" charset="-120"/>
               </a:rPr>
-              <a:t>        current + 1,</a:t>
+              <a:t>current + 1,</a:t>
             </a:r>
             <a:endParaRPr lang="en-US" sz="1280" dirty="0"/>
           </a:p>
@@ -12930,7 +12930,7 @@
                 <a:ea typeface="Consolas" pitchFamily="34" charset="-122"/>
                 <a:cs typeface="Consolas" pitchFamily="34" charset="-120"/>
               </a:rPr>
-              <a:t>        commands.Count - current - 1);</a:t>
+              <a:t>commands.Count - current - 1);</a:t>
             </a:r>
             <a:endParaRPr lang="en-US" sz="1280" dirty="0"/>
           </a:p>
@@ -12953,7 +12953,7 @@
                 <a:ea typeface="Consolas" pitchFamily="34" charset="-122"/>
                 <a:cs typeface="Consolas" pitchFamily="34" charset="-120"/>
               </a:rPr>
-              <a:t>    commands.Add(command);</a:t>
+              <a:t>commands.Add(command);</a:t>
             </a:r>
             <a:endParaRPr lang="en-US" sz="1280" dirty="0"/>
           </a:p>
@@ -12970,7 +12970,7 @@
                 <a:ea typeface="Consolas" pitchFamily="34" charset="-122"/>
                 <a:cs typeface="Consolas" pitchFamily="34" charset="-120"/>
               </a:rPr>
-              <a:t>    current++;</a:t>
+              <a:t>current++;</a:t>
             </a:r>
             <a:endParaRPr lang="en-US" sz="1280" dirty="0"/>
           </a:p>
@@ -12987,7 +12987,7 @@
                 <a:ea typeface="Consolas" pitchFamily="34" charset="-122"/>
                 <a:cs typeface="Consolas" pitchFamily="34" charset="-120"/>
               </a:rPr>
-              <a:t>    command.Execute();</a:t>
+              <a:t>command.Execute();</a:t>
             </a:r>
             <a:endParaRPr lang="en-US" sz="1280" dirty="0"/>
           </a:p>
@@ -13164,7 +13164,7 @@
                 <a:ea typeface="Malgun Gothic" pitchFamily="34" charset="-122"/>
                 <a:cs typeface="Malgun Gothic" pitchFamily="34" charset="-120"/>
               </a:rPr>
-              <a:t>Game Programming Patterns - Command | Unity/C#</a:t>
+              <a:t>Command | Unity/C#</a:t>
             </a:r>
             <a:endParaRPr lang="en-US" sz="700" dirty="0"/>
           </a:p>
@@ -13350,7 +13350,7 @@
                 <a:ea typeface="Consolas" pitchFamily="34" charset="-122"/>
                 <a:cs typeface="Consolas" pitchFamily="34" charset="-120"/>
               </a:rPr>
-              <a:t>    if (current &lt; 0) return;</a:t>
+              <a:t>if (current &lt; 0) return;</a:t>
             </a:r>
             <a:endParaRPr lang="en-US" sz="1190" dirty="0"/>
           </a:p>
@@ -13367,7 +13367,7 @@
                 <a:ea typeface="Consolas" pitchFamily="34" charset="-122"/>
                 <a:cs typeface="Consolas" pitchFamily="34" charset="-120"/>
               </a:rPr>
-              <a:t>    commands[current].Undo();</a:t>
+              <a:t>commands[current].Undo();</a:t>
             </a:r>
             <a:endParaRPr lang="en-US" sz="1190" dirty="0"/>
           </a:p>
@@ -13384,7 +13384,7 @@
                 <a:ea typeface="Consolas" pitchFamily="34" charset="-122"/>
                 <a:cs typeface="Consolas" pitchFamily="34" charset="-120"/>
               </a:rPr>
-              <a:t>    current--;</a:t>
+              <a:t>current--;</a:t>
             </a:r>
             <a:endParaRPr lang="en-US" sz="1190" dirty="0"/>
           </a:p>
@@ -13458,7 +13458,7 @@
                 <a:ea typeface="Consolas" pitchFamily="34" charset="-122"/>
                 <a:cs typeface="Consolas" pitchFamily="34" charset="-120"/>
               </a:rPr>
-              <a:t>    if (current + 1 &gt;= commands.Count) return;</a:t>
+              <a:t>if (current + 1 &gt;= commands.Count) return;</a:t>
             </a:r>
             <a:endParaRPr lang="en-US" sz="1190" dirty="0"/>
           </a:p>
@@ -13475,7 +13475,7 @@
                 <a:ea typeface="Consolas" pitchFamily="34" charset="-122"/>
                 <a:cs typeface="Consolas" pitchFamily="34" charset="-120"/>
               </a:rPr>
-              <a:t>    current++;</a:t>
+              <a:t>current++;</a:t>
             </a:r>
             <a:endParaRPr lang="en-US" sz="1190" dirty="0"/>
           </a:p>
@@ -13492,7 +13492,7 @@
                 <a:ea typeface="Consolas" pitchFamily="34" charset="-122"/>
                 <a:cs typeface="Consolas" pitchFamily="34" charset="-120"/>
               </a:rPr>
-              <a:t>    commands[current].Execute();</a:t>
+              <a:t>commands[current].Execute();</a:t>
             </a:r>
             <a:endParaRPr lang="en-US" sz="1190" dirty="0"/>
           </a:p>
@@ -13669,7 +13669,7 @@
                 <a:ea typeface="Malgun Gothic" pitchFamily="34" charset="-122"/>
                 <a:cs typeface="Malgun Gothic" pitchFamily="34" charset="-120"/>
               </a:rPr>
-              <a:t>Game Programming Patterns - Command | Unity/C#</a:t>
+              <a:t>Command | Unity/C#</a:t>
             </a:r>
             <a:endParaRPr lang="en-US" sz="700" dirty="0"/>
           </a:p>
@@ -14423,7 +14423,7 @@
                 <a:ea typeface="Malgun Gothic" pitchFamily="34" charset="-122"/>
                 <a:cs typeface="Malgun Gothic" pitchFamily="34" charset="-120"/>
               </a:rPr>
-              <a:t>Game Programming Patterns - Command | Unity/C#</a:t>
+              <a:t>Command | Unity/C#</a:t>
             </a:r>
             <a:endParaRPr lang="en-US" sz="700" dirty="0"/>
           </a:p>
@@ -14863,7 +14863,7 @@
                 <a:ea typeface="Malgun Gothic" pitchFamily="34" charset="-122"/>
                 <a:cs typeface="Malgun Gothic" pitchFamily="34" charset="-120"/>
               </a:rPr>
-              <a:t>Game Programming Patterns - Command | Unity/C#</a:t>
+              <a:t>Command | Unity/C#</a:t>
             </a:r>
             <a:endParaRPr lang="en-US" sz="700" dirty="0"/>
           </a:p>
@@ -15303,7 +15303,7 @@
                 <a:ea typeface="Malgun Gothic" pitchFamily="34" charset="-122"/>
                 <a:cs typeface="Malgun Gothic" pitchFamily="34" charset="-120"/>
               </a:rPr>
-              <a:t>Game Programming Patterns - Command | Unity/C#</a:t>
+              <a:t>Command | Unity/C#</a:t>
             </a:r>
             <a:endParaRPr lang="en-US" sz="700" dirty="0"/>
           </a:p>
@@ -15489,7 +15489,7 @@
                 <a:ea typeface="Consolas" pitchFamily="34" charset="-122"/>
                 <a:cs typeface="Consolas" pitchFamily="34" charset="-120"/>
               </a:rPr>
-              <a:t>    private readonly Action action;</a:t>
+              <a:t>private readonly Action action;</a:t>
             </a:r>
             <a:endParaRPr lang="en-US" sz="1270" dirty="0"/>
           </a:p>
@@ -15512,7 +15512,7 @@
                 <a:ea typeface="Consolas" pitchFamily="34" charset="-122"/>
                 <a:cs typeface="Consolas" pitchFamily="34" charset="-120"/>
               </a:rPr>
-              <a:t>    public ActionCommand(Action action)</a:t>
+              <a:t>public ActionCommand(Action action)</a:t>
             </a:r>
             <a:endParaRPr lang="en-US" sz="1270" dirty="0"/>
           </a:p>
@@ -15529,7 +15529,7 @@
                 <a:ea typeface="Consolas" pitchFamily="34" charset="-122"/>
                 <a:cs typeface="Consolas" pitchFamily="34" charset="-120"/>
               </a:rPr>
-              <a:t>    {</a:t>
+              <a:t>{</a:t>
             </a:r>
             <a:endParaRPr lang="en-US" sz="1270" dirty="0"/>
           </a:p>
@@ -15546,7 +15546,7 @@
                 <a:ea typeface="Consolas" pitchFamily="34" charset="-122"/>
                 <a:cs typeface="Consolas" pitchFamily="34" charset="-120"/>
               </a:rPr>
-              <a:t>        this.action = action;</a:t>
+              <a:t>this.action = action;</a:t>
             </a:r>
             <a:endParaRPr lang="en-US" sz="1270" dirty="0"/>
           </a:p>
@@ -15563,7 +15563,7 @@
                 <a:ea typeface="Consolas" pitchFamily="34" charset="-122"/>
                 <a:cs typeface="Consolas" pitchFamily="34" charset="-120"/>
               </a:rPr>
-              <a:t>    }</a:t>
+              <a:t>}</a:t>
             </a:r>
             <a:endParaRPr lang="en-US" sz="1270" dirty="0"/>
           </a:p>
@@ -15586,7 +15586,7 @@
                 <a:ea typeface="Consolas" pitchFamily="34" charset="-122"/>
                 <a:cs typeface="Consolas" pitchFamily="34" charset="-120"/>
               </a:rPr>
-              <a:t>    public void Execute() =&gt; action?.Invoke();</a:t>
+              <a:t>public void Execute() =&gt; action?.Invoke();</a:t>
             </a:r>
             <a:endParaRPr lang="en-US" sz="1270" dirty="0"/>
           </a:p>
@@ -15763,7 +15763,7 @@
                 <a:ea typeface="Malgun Gothic" pitchFamily="34" charset="-122"/>
                 <a:cs typeface="Malgun Gothic" pitchFamily="34" charset="-120"/>
               </a:rPr>
-              <a:t>Game Programming Patterns - Command | Unity/C#</a:t>
+              <a:t>Command | Unity/C#</a:t>
             </a:r>
             <a:endParaRPr lang="en-US" sz="700" dirty="0"/>
           </a:p>
@@ -15804,7 +15804,7 @@
                 <a:ea typeface="Malgun Gothic" pitchFamily="34" charset="-122"/>
                 <a:cs typeface="Malgun Gothic" pitchFamily="34" charset="-120"/>
               </a:rPr>
-              <a:t>원문 장의 전체 흐름</a:t>
+              <a:t>학습 흐름</a:t>
             </a:r>
             <a:endParaRPr lang="en-US" sz="2500" dirty="0"/>
           </a:p>
@@ -16228,7 +16228,7 @@
                 <a:ea typeface="Malgun Gothic" pitchFamily="34" charset="-122"/>
                 <a:cs typeface="Malgun Gothic" pitchFamily="34" charset="-120"/>
               </a:rPr>
-              <a:t>Game Programming Patterns - Command | Unity/C#</a:t>
+              <a:t>Command | Unity/C#</a:t>
             </a:r>
             <a:endParaRPr lang="en-US" sz="700" dirty="0"/>
           </a:p>
@@ -16627,7 +16627,7 @@
                 <a:ea typeface="Malgun Gothic" pitchFamily="34" charset="-122"/>
                 <a:cs typeface="Malgun Gothic" pitchFamily="34" charset="-120"/>
               </a:rPr>
-              <a:t>Game Programming Patterns - Command | Unity/C#</a:t>
+              <a:t>Command | Unity/C#</a:t>
             </a:r>
             <a:endParaRPr lang="en-US" sz="700" dirty="0"/>
           </a:p>
@@ -17092,7 +17092,7 @@
                 <a:ea typeface="Malgun Gothic" pitchFamily="34" charset="-122"/>
                 <a:cs typeface="Malgun Gothic" pitchFamily="34" charset="-120"/>
               </a:rPr>
-              <a:t>Game Programming Patterns - Command | Unity/C#</a:t>
+              <a:t>Command | Unity/C#</a:t>
             </a:r>
             <a:endParaRPr lang="en-US" sz="700" dirty="0"/>
           </a:p>
@@ -17557,7 +17557,7 @@
                 <a:ea typeface="Malgun Gothic" pitchFamily="34" charset="-122"/>
                 <a:cs typeface="Malgun Gothic" pitchFamily="34" charset="-120"/>
               </a:rPr>
-              <a:t>Game Programming Patterns - Command | Unity/C#</a:t>
+              <a:t>Command | Unity/C#</a:t>
             </a:r>
             <a:endParaRPr lang="en-US" sz="700" dirty="0"/>
           </a:p>
@@ -18311,7 +18311,7 @@
                 <a:ea typeface="Malgun Gothic" pitchFamily="34" charset="-122"/>
                 <a:cs typeface="Malgun Gothic" pitchFamily="34" charset="-120"/>
               </a:rPr>
-              <a:t>Game Programming Patterns - Command | Unity/C#</a:t>
+              <a:t>Command | Unity/C#</a:t>
             </a:r>
             <a:endParaRPr lang="en-US" sz="700" dirty="0"/>
           </a:p>
@@ -18839,7 +18839,7 @@
                 <a:ea typeface="Malgun Gothic" pitchFamily="34" charset="-122"/>
                 <a:cs typeface="Malgun Gothic" pitchFamily="34" charset="-120"/>
               </a:rPr>
-              <a:t>Game Programming Patterns - Command | Unity/C#</a:t>
+              <a:t>Command | Unity/C#</a:t>
             </a:r>
             <a:endParaRPr lang="en-US" sz="700" dirty="0"/>
           </a:p>
@@ -19367,7 +19367,7 @@
                 <a:ea typeface="Malgun Gothic" pitchFamily="34" charset="-122"/>
                 <a:cs typeface="Malgun Gothic" pitchFamily="34" charset="-120"/>
               </a:rPr>
-              <a:t>Game Programming Patterns - Command | Unity/C#</a:t>
+              <a:t>Command | Unity/C#</a:t>
             </a:r>
             <a:endParaRPr lang="en-US" sz="700" dirty="0"/>
           </a:p>
@@ -19895,7 +19895,7 @@
                 <a:ea typeface="Malgun Gothic" pitchFamily="34" charset="-122"/>
                 <a:cs typeface="Malgun Gothic" pitchFamily="34" charset="-120"/>
               </a:rPr>
-              <a:t>Game Programming Patterns - Command | Unity/C#</a:t>
+              <a:t>Command | Unity/C#</a:t>
             </a:r>
             <a:endParaRPr lang="en-US" sz="700" dirty="0"/>
           </a:p>
@@ -20423,7 +20423,7 @@
                 <a:ea typeface="Malgun Gothic" pitchFamily="34" charset="-122"/>
                 <a:cs typeface="Malgun Gothic" pitchFamily="34" charset="-120"/>
               </a:rPr>
-              <a:t>Game Programming Patterns - Command | Unity/C#</a:t>
+              <a:t>Command | Unity/C#</a:t>
             </a:r>
             <a:endParaRPr lang="en-US" sz="700" dirty="0"/>
           </a:p>
@@ -20951,7 +20951,7 @@
                 <a:ea typeface="Malgun Gothic" pitchFamily="34" charset="-122"/>
                 <a:cs typeface="Malgun Gothic" pitchFamily="34" charset="-120"/>
               </a:rPr>
-              <a:t>Game Programming Patterns - Command | Unity/C#</a:t>
+              <a:t>Command | Unity/C#</a:t>
             </a:r>
             <a:endParaRPr lang="en-US" sz="700" dirty="0"/>
           </a:p>
@@ -21479,7 +21479,7 @@
                 <a:ea typeface="Malgun Gothic" pitchFamily="34" charset="-122"/>
                 <a:cs typeface="Malgun Gothic" pitchFamily="34" charset="-120"/>
               </a:rPr>
-              <a:t>Game Programming Patterns - Command | Unity/C#</a:t>
+              <a:t>Command | Unity/C#</a:t>
             </a:r>
             <a:endParaRPr lang="en-US" sz="700" dirty="0"/>
           </a:p>
@@ -21520,7 +21520,7 @@
                 <a:ea typeface="Malgun Gothic" pitchFamily="34" charset="-122"/>
                 <a:cs typeface="Malgun Gothic" pitchFamily="34" charset="-120"/>
               </a:rPr>
-              <a:t>원문 장의 전체 흐름 2</a:t>
+              <a:t>학습 흐름 2</a:t>
             </a:r>
             <a:endParaRPr lang="en-US" sz="2500" dirty="0"/>
           </a:p>
@@ -21944,7 +21944,7 @@
                 <a:ea typeface="Malgun Gothic" pitchFamily="34" charset="-122"/>
                 <a:cs typeface="Malgun Gothic" pitchFamily="34" charset="-120"/>
               </a:rPr>
-              <a:t>Game Programming Patterns - Command | Unity/C#</a:t>
+              <a:t>Command | Unity/C#</a:t>
             </a:r>
             <a:endParaRPr lang="en-US" sz="700" dirty="0"/>
           </a:p>
@@ -22384,7 +22384,7 @@
                 <a:ea typeface="Malgun Gothic" pitchFamily="34" charset="-122"/>
                 <a:cs typeface="Malgun Gothic" pitchFamily="34" charset="-120"/>
               </a:rPr>
-              <a:t>Game Programming Patterns - Command | Unity/C#</a:t>
+              <a:t>Command | Unity/C#</a:t>
             </a:r>
             <a:endParaRPr lang="en-US" sz="700" dirty="0"/>
           </a:p>
@@ -22570,7 +22570,7 @@
                 <a:ea typeface="Consolas" pitchFamily="34" charset="-122"/>
                 <a:cs typeface="Consolas" pitchFamily="34" charset="-120"/>
               </a:rPr>
-              <a:t>    if (Input.GetKeyDown(KeyCode.X)) Jump();</a:t>
+              <a:t>if (Input.GetKeyDown(KeyCode.X)) Jump();</a:t>
             </a:r>
             <a:endParaRPr lang="en-US" sz="1360" dirty="0"/>
           </a:p>
@@ -22587,7 +22587,7 @@
                 <a:ea typeface="Consolas" pitchFamily="34" charset="-122"/>
                 <a:cs typeface="Consolas" pitchFamily="34" charset="-120"/>
               </a:rPr>
-              <a:t>    else if (Input.GetKeyDown(KeyCode.Y)) FireGun();</a:t>
+              <a:t>else if (Input.GetKeyDown(KeyCode.Y)) FireGun();</a:t>
             </a:r>
             <a:endParaRPr lang="en-US" sz="1360" dirty="0"/>
           </a:p>
@@ -22604,7 +22604,7 @@
                 <a:ea typeface="Consolas" pitchFamily="34" charset="-122"/>
                 <a:cs typeface="Consolas" pitchFamily="34" charset="-120"/>
               </a:rPr>
-              <a:t>    else if (Input.GetKeyDown(KeyCode.A)) SwapWeapon();</a:t>
+              <a:t>else if (Input.GetKeyDown(KeyCode.A)) SwapWeapon();</a:t>
             </a:r>
             <a:endParaRPr lang="en-US" sz="1360" dirty="0"/>
           </a:p>
@@ -22621,7 +22621,7 @@
                 <a:ea typeface="Consolas" pitchFamily="34" charset="-122"/>
                 <a:cs typeface="Consolas" pitchFamily="34" charset="-120"/>
               </a:rPr>
-              <a:t>    else if (Input.GetKeyDown(KeyCode.B)) LurchIneffectively();</a:t>
+              <a:t>else if (Input.GetKeyDown(KeyCode.B)) LurchIneffectively();</a:t>
             </a:r>
             <a:endParaRPr lang="en-US" sz="1360" dirty="0"/>
           </a:p>
@@ -22798,7 +22798,7 @@
                 <a:ea typeface="Malgun Gothic" pitchFamily="34" charset="-122"/>
                 <a:cs typeface="Malgun Gothic" pitchFamily="34" charset="-120"/>
               </a:rPr>
-              <a:t>Game Programming Patterns - Command | Unity/C#</a:t>
+              <a:t>Command | Unity/C#</a:t>
             </a:r>
             <a:endParaRPr lang="en-US" sz="700" dirty="0"/>
           </a:p>
@@ -23238,7 +23238,7 @@
                 <a:ea typeface="Malgun Gothic" pitchFamily="34" charset="-122"/>
                 <a:cs typeface="Malgun Gothic" pitchFamily="34" charset="-120"/>
               </a:rPr>
-              <a:t>Game Programming Patterns - Command | Unity/C#</a:t>
+              <a:t>Command | Unity/C#</a:t>
             </a:r>
             <a:endParaRPr lang="en-US" sz="700" dirty="0"/>
           </a:p>
@@ -23678,7 +23678,7 @@
                 <a:ea typeface="Malgun Gothic" pitchFamily="34" charset="-122"/>
                 <a:cs typeface="Malgun Gothic" pitchFamily="34" charset="-120"/>
               </a:rPr>
-              <a:t>Game Programming Patterns - Command | Unity/C#</a:t>
+              <a:t>Command | Unity/C#</a:t>
             </a:r>
             <a:endParaRPr lang="en-US" sz="700" dirty="0"/>
           </a:p>
@@ -23864,7 +23864,7 @@
                 <a:ea typeface="Consolas" pitchFamily="34" charset="-122"/>
                 <a:cs typeface="Consolas" pitchFamily="34" charset="-120"/>
               </a:rPr>
-              <a:t>    void Execute();</a:t>
+              <a:t>void Execute();</a:t>
             </a:r>
             <a:endParaRPr lang="en-US" sz="1340" dirty="0"/>
           </a:p>
@@ -23938,7 +23938,7 @@
                 <a:ea typeface="Consolas" pitchFamily="34" charset="-122"/>
                 <a:cs typeface="Consolas" pitchFamily="34" charset="-120"/>
               </a:rPr>
-              <a:t>    public void Execute()</a:t>
+              <a:t>public void Execute()</a:t>
             </a:r>
             <a:endParaRPr lang="en-US" sz="1340" dirty="0"/>
           </a:p>
@@ -23955,7 +23955,7 @@
                 <a:ea typeface="Consolas" pitchFamily="34" charset="-122"/>
                 <a:cs typeface="Consolas" pitchFamily="34" charset="-120"/>
               </a:rPr>
-              <a:t>    {</a:t>
+              <a:t>{</a:t>
             </a:r>
             <a:endParaRPr lang="en-US" sz="1340" dirty="0"/>
           </a:p>
@@ -23972,7 +23972,7 @@
                 <a:ea typeface="Consolas" pitchFamily="34" charset="-122"/>
                 <a:cs typeface="Consolas" pitchFamily="34" charset="-120"/>
               </a:rPr>
-              <a:t>        PlayerActions.Jump();</a:t>
+              <a:t>PlayerActions.Jump();</a:t>
             </a:r>
             <a:endParaRPr lang="en-US" sz="1340" dirty="0"/>
           </a:p>
@@ -23989,7 +23989,7 @@
                 <a:ea typeface="Consolas" pitchFamily="34" charset="-122"/>
                 <a:cs typeface="Consolas" pitchFamily="34" charset="-120"/>
               </a:rPr>
-              <a:t>    }</a:t>
+              <a:t>}</a:t>
             </a:r>
             <a:endParaRPr lang="en-US" sz="1340" dirty="0"/>
           </a:p>
@@ -24166,7 +24166,7 @@
                 <a:ea typeface="Malgun Gothic" pitchFamily="34" charset="-122"/>
                 <a:cs typeface="Malgun Gothic" pitchFamily="34" charset="-120"/>
               </a:rPr>
-              <a:t>Game Programming Patterns - Command | Unity/C#</a:t>
+              <a:t>Command | Unity/C#</a:t>
             </a:r>
             <a:endParaRPr lang="en-US" sz="700" dirty="0"/>
           </a:p>
@@ -24352,7 +24352,7 @@
                 <a:ea typeface="Consolas" pitchFamily="34" charset="-122"/>
                 <a:cs typeface="Consolas" pitchFamily="34" charset="-120"/>
               </a:rPr>
-              <a:t>    public ICommand ButtonX { get; set; }</a:t>
+              <a:t>public ICommand ButtonX { get; set; }</a:t>
             </a:r>
             <a:endParaRPr lang="en-US" sz="1270" dirty="0"/>
           </a:p>
@@ -24369,7 +24369,7 @@
                 <a:ea typeface="Consolas" pitchFamily="34" charset="-122"/>
                 <a:cs typeface="Consolas" pitchFamily="34" charset="-120"/>
               </a:rPr>
-              <a:t>    public ICommand ButtonY { get; set; }</a:t>
+              <a:t>public ICommand ButtonY { get; set; }</a:t>
             </a:r>
             <a:endParaRPr lang="en-US" sz="1270" dirty="0"/>
           </a:p>
@@ -24392,7 +24392,7 @@
                 <a:ea typeface="Consolas" pitchFamily="34" charset="-122"/>
                 <a:cs typeface="Consolas" pitchFamily="34" charset="-120"/>
               </a:rPr>
-              <a:t>    void Update()</a:t>
+              <a:t>void Update()</a:t>
             </a:r>
             <a:endParaRPr lang="en-US" sz="1270" dirty="0"/>
           </a:p>
@@ -24409,7 +24409,7 @@
                 <a:ea typeface="Consolas" pitchFamily="34" charset="-122"/>
                 <a:cs typeface="Consolas" pitchFamily="34" charset="-120"/>
               </a:rPr>
-              <a:t>    {</a:t>
+              <a:t>{</a:t>
             </a:r>
             <a:endParaRPr lang="en-US" sz="1270" dirty="0"/>
           </a:p>
@@ -24426,7 +24426,7 @@
                 <a:ea typeface="Consolas" pitchFamily="34" charset="-122"/>
                 <a:cs typeface="Consolas" pitchFamily="34" charset="-120"/>
               </a:rPr>
-              <a:t>        if (Input.GetKeyDown(KeyCode.X)) ButtonX.Execute();</a:t>
+              <a:t>if (Input.GetKeyDown(KeyCode.X)) ButtonX.Execute();</a:t>
             </a:r>
             <a:endParaRPr lang="en-US" sz="1270" dirty="0"/>
           </a:p>
@@ -24443,7 +24443,7 @@
                 <a:ea typeface="Consolas" pitchFamily="34" charset="-122"/>
                 <a:cs typeface="Consolas" pitchFamily="34" charset="-120"/>
               </a:rPr>
-              <a:t>        if (Input.GetKeyDown(KeyCode.Y)) ButtonY.Execute();</a:t>
+              <a:t>if (Input.GetKeyDown(KeyCode.Y)) ButtonY.Execute();</a:t>
             </a:r>
             <a:endParaRPr lang="en-US" sz="1270" dirty="0"/>
           </a:p>
@@ -24460,7 +24460,7 @@
                 <a:ea typeface="Consolas" pitchFamily="34" charset="-122"/>
                 <a:cs typeface="Consolas" pitchFamily="34" charset="-120"/>
               </a:rPr>
-              <a:t>    }</a:t>
+              <a:t>}</a:t>
             </a:r>
             <a:endParaRPr lang="en-US" sz="1270" dirty="0"/>
           </a:p>

</xml_diff>